<commit_message>
Fix slide 13 label overflow (Wilson CI / honest labels cards)
</commit_message>
<xml_diff>
--- a/06_Presentation/PadelLens_Deck_v5_FINAL.pptx
+++ b/06_Presentation/PadelLens_Deck_v5_FINAL.pptx
@@ -7730,24 +7730,24 @@
         </p:nvSpPr>
         <p:spPr>
           <a:xfrm>
-            <a:off x="685800" y="2770632"/>
-            <a:ext cx="2011680" cy="502920"/>
-          </a:xfrm>
-          <a:prstGeom prst="rect">
-            <a:avLst/>
-          </a:prstGeom>
-          <a:noFill/>
-          <a:ln/>
-        </p:spPr>
-        <p:txBody>
-          <a:bodyPr wrap="square" lIns="0" tIns="0" rIns="0" bIns="0" rtlCol="0" anchor="ctr"/>
-          <a:lstStyle/>
-          <a:p>
-            <a:pPr marL="0" indent="0">
-              <a:buNone/>
-            </a:pPr>
-            <a:r>
-              <a:rPr lang="en-US" sz="2800" b="1" dirty="0">
+            <a:off x="685800" y="2830000"/>
+            <a:ext cx="2011680" cy="360000"/>
+          </a:xfrm>
+          <a:prstGeom prst="rect">
+            <a:avLst/>
+          </a:prstGeom>
+          <a:noFill/>
+          <a:ln/>
+        </p:spPr>
+        <p:txBody>
+          <a:bodyPr wrap="square" lIns="0" tIns="0" rIns="0" bIns="0" rtlCol="0" anchor="ctr"/>
+          <a:lstStyle/>
+          <a:p>
+            <a:pPr marL="0" indent="0">
+              <a:buNone/>
+            </a:pPr>
+            <a:r>
+              <a:rPr lang="en-US" sz="1900" b="1" dirty="0">
                 <a:solidFill>
                   <a:srgbClr val="1F2937"/>
                 </a:solidFill>
@@ -7933,24 +7933,24 @@
         </p:nvSpPr>
         <p:spPr>
           <a:xfrm>
-            <a:off x="685800" y="3849624"/>
-            <a:ext cx="2011680" cy="502920"/>
-          </a:xfrm>
-          <a:prstGeom prst="rect">
-            <a:avLst/>
-          </a:prstGeom>
-          <a:noFill/>
-          <a:ln/>
-        </p:spPr>
-        <p:txBody>
-          <a:bodyPr wrap="square" lIns="0" tIns="0" rIns="0" bIns="0" rtlCol="0" anchor="ctr"/>
-          <a:lstStyle/>
-          <a:p>
-            <a:pPr marL="0" indent="0">
-              <a:buNone/>
-            </a:pPr>
-            <a:r>
-              <a:rPr lang="en-US" sz="2800" b="1" dirty="0">
+            <a:off x="685800" y="3909000"/>
+            <a:ext cx="2011680" cy="360000"/>
+          </a:xfrm>
+          <a:prstGeom prst="rect">
+            <a:avLst/>
+          </a:prstGeom>
+          <a:noFill/>
+          <a:ln/>
+        </p:spPr>
+        <p:txBody>
+          <a:bodyPr wrap="square" lIns="0" tIns="0" rIns="0" bIns="0" rtlCol="0" anchor="ctr"/>
+          <a:lstStyle/>
+          <a:p>
+            <a:pPr marL="0" indent="0">
+              <a:buNone/>
+            </a:pPr>
+            <a:r>
+              <a:rPr lang="en-US" sz="1900" b="1" dirty="0">
                 <a:solidFill>
                   <a:srgbClr val="1F2937"/>
                 </a:solidFill>

</xml_diff>